<commit_message>
added about in home page
</commit_message>
<xml_diff>
--- a/OmerMazorWebsite/powerpoint.pptx
+++ b/OmerMazorWebsite/powerpoint.pptx
@@ -259,7 +259,7 @@
           <a:p>
             <a:fld id="{A37E1BEB-A74B-468E-BE92-E22733075392}" type="datetimeFigureOut">
               <a:rPr lang="he-IL" smtClean="0"/>
-              <a:t>ה'/כסלו/תשפ"ו</a:t>
+              <a:t>י"א/אייר/תשפ"ו</a:t>
             </a:fld>
             <a:endParaRPr lang="he-IL"/>
           </a:p>
@@ -457,7 +457,7 @@
           <a:p>
             <a:fld id="{A37E1BEB-A74B-468E-BE92-E22733075392}" type="datetimeFigureOut">
               <a:rPr lang="he-IL" smtClean="0"/>
-              <a:t>ה'/כסלו/תשפ"ו</a:t>
+              <a:t>י"א/אייר/תשפ"ו</a:t>
             </a:fld>
             <a:endParaRPr lang="he-IL"/>
           </a:p>
@@ -665,7 +665,7 @@
           <a:p>
             <a:fld id="{A37E1BEB-A74B-468E-BE92-E22733075392}" type="datetimeFigureOut">
               <a:rPr lang="he-IL" smtClean="0"/>
-              <a:t>ה'/כסלו/תשפ"ו</a:t>
+              <a:t>י"א/אייר/תשפ"ו</a:t>
             </a:fld>
             <a:endParaRPr lang="he-IL"/>
           </a:p>
@@ -863,7 +863,7 @@
           <a:p>
             <a:fld id="{A37E1BEB-A74B-468E-BE92-E22733075392}" type="datetimeFigureOut">
               <a:rPr lang="he-IL" smtClean="0"/>
-              <a:t>ה'/כסלו/תשפ"ו</a:t>
+              <a:t>י"א/אייר/תשפ"ו</a:t>
             </a:fld>
             <a:endParaRPr lang="he-IL"/>
           </a:p>
@@ -1138,7 +1138,7 @@
           <a:p>
             <a:fld id="{A37E1BEB-A74B-468E-BE92-E22733075392}" type="datetimeFigureOut">
               <a:rPr lang="he-IL" smtClean="0"/>
-              <a:t>ה'/כסלו/תשפ"ו</a:t>
+              <a:t>י"א/אייר/תשפ"ו</a:t>
             </a:fld>
             <a:endParaRPr lang="he-IL"/>
           </a:p>
@@ -1403,7 +1403,7 @@
           <a:p>
             <a:fld id="{A37E1BEB-A74B-468E-BE92-E22733075392}" type="datetimeFigureOut">
               <a:rPr lang="he-IL" smtClean="0"/>
-              <a:t>ה'/כסלו/תשפ"ו</a:t>
+              <a:t>י"א/אייר/תשפ"ו</a:t>
             </a:fld>
             <a:endParaRPr lang="he-IL"/>
           </a:p>
@@ -1815,7 +1815,7 @@
           <a:p>
             <a:fld id="{A37E1BEB-A74B-468E-BE92-E22733075392}" type="datetimeFigureOut">
               <a:rPr lang="he-IL" smtClean="0"/>
-              <a:t>ה'/כסלו/תשפ"ו</a:t>
+              <a:t>י"א/אייר/תשפ"ו</a:t>
             </a:fld>
             <a:endParaRPr lang="he-IL"/>
           </a:p>
@@ -1956,7 +1956,7 @@
           <a:p>
             <a:fld id="{A37E1BEB-A74B-468E-BE92-E22733075392}" type="datetimeFigureOut">
               <a:rPr lang="he-IL" smtClean="0"/>
-              <a:t>ה'/כסלו/תשפ"ו</a:t>
+              <a:t>י"א/אייר/תשפ"ו</a:t>
             </a:fld>
             <a:endParaRPr lang="he-IL"/>
           </a:p>
@@ -2069,7 +2069,7 @@
           <a:p>
             <a:fld id="{A37E1BEB-A74B-468E-BE92-E22733075392}" type="datetimeFigureOut">
               <a:rPr lang="he-IL" smtClean="0"/>
-              <a:t>ה'/כסלו/תשפ"ו</a:t>
+              <a:t>י"א/אייר/תשפ"ו</a:t>
             </a:fld>
             <a:endParaRPr lang="he-IL"/>
           </a:p>
@@ -2380,7 +2380,7 @@
           <a:p>
             <a:fld id="{A37E1BEB-A74B-468E-BE92-E22733075392}" type="datetimeFigureOut">
               <a:rPr lang="he-IL" smtClean="0"/>
-              <a:t>ה'/כסלו/תשפ"ו</a:t>
+              <a:t>י"א/אייר/תשפ"ו</a:t>
             </a:fld>
             <a:endParaRPr lang="he-IL"/>
           </a:p>
@@ -2668,7 +2668,7 @@
           <a:p>
             <a:fld id="{A37E1BEB-A74B-468E-BE92-E22733075392}" type="datetimeFigureOut">
               <a:rPr lang="he-IL" smtClean="0"/>
-              <a:t>ה'/כסלו/תשפ"ו</a:t>
+              <a:t>י"א/אייר/תשפ"ו</a:t>
             </a:fld>
             <a:endParaRPr lang="he-IL"/>
           </a:p>
@@ -2909,7 +2909,7 @@
           <a:p>
             <a:fld id="{A37E1BEB-A74B-468E-BE92-E22733075392}" type="datetimeFigureOut">
               <a:rPr lang="he-IL" smtClean="0"/>
-              <a:t>ה'/כסלו/תשפ"ו</a:t>
+              <a:t>י"א/אייר/תשפ"ו</a:t>
             </a:fld>
             <a:endParaRPr lang="he-IL"/>
           </a:p>
@@ -3760,6 +3760,59 @@
           </a:p>
         </p:txBody>
       </p:sp>
+      <p:sp>
+        <p:nvSpPr>
+          <p:cNvPr id="2" name="מלבן: פינות מעוגלות 10">
+            <a:extLst>
+              <a:ext uri="{FF2B5EF4-FFF2-40B4-BE49-F238E27FC236}">
+                <a16:creationId xmlns:a16="http://schemas.microsoft.com/office/drawing/2014/main" id="{095DDA6F-1351-59C0-46C4-278522A0AAA4}"/>
+              </a:ext>
+            </a:extLst>
+          </p:cNvPr>
+          <p:cNvSpPr/>
+          <p:nvPr/>
+        </p:nvSpPr>
+        <p:spPr>
+          <a:xfrm>
+            <a:off x="8171688" y="1088136"/>
+            <a:ext cx="1737360" cy="704088"/>
+          </a:xfrm>
+          <a:prstGeom prst="roundRect">
+            <a:avLst/>
+          </a:prstGeom>
+        </p:spPr>
+        <p:style>
+          <a:lnRef idx="2">
+            <a:schemeClr val="accent1">
+              <a:shade val="15000"/>
+            </a:schemeClr>
+          </a:lnRef>
+          <a:fillRef idx="1">
+            <a:schemeClr val="accent1"/>
+          </a:fillRef>
+          <a:effectRef idx="0">
+            <a:schemeClr val="accent1"/>
+          </a:effectRef>
+          <a:fontRef idx="minor">
+            <a:schemeClr val="lt1"/>
+          </a:fontRef>
+        </p:style>
+        <p:txBody>
+          <a:bodyPr rtlCol="1" anchor="ctr"/>
+          <a:lstStyle/>
+          <a:p>
+            <a:pPr algn="ctr"/>
+            <a:r>
+              <a:rPr lang="en-US" dirty="0">
+                <a:solidFill>
+                  <a:schemeClr val="bg1"/>
+                </a:solidFill>
+              </a:rPr>
+              <a:t>Gallery</a:t>
+            </a:r>
+          </a:p>
+        </p:txBody>
+      </p:sp>
     </p:spTree>
     <p:extLst>
       <p:ext uri="{BB962C8B-B14F-4D97-AF65-F5344CB8AC3E}">

</xml_diff>